<commit_message>
Keep the deck's own margin on all four sides
Every footer and the closing contact line sat 0.28in off the bottom edge, well
inside the 0.5in margin the rest of the deck keeps. The geometry audit only
checked left and right, so nothing flagged it. The check now runs vertically
too, the footers moved up, and the body text above each one was shortened to
make room rather than pushed into it.

Also on this pass: the caveat under the zero-markup line was set in the sky
tint, which is borderline against navy at 11pt on a projector, so it moves to a
lighter one; the two-key rule now fills the left column of the liaison slide,
which was running to the foot of the sheet empty; and the footnote under the
rate cards was one 10.5pt line in a 0.3in box with no room for a descender.

Co-Authored-By: Claude Opus 5 <noreply@anthropic.com>
Claude-Session: https://claude.ai/code/session_019agcJUSzk7gnhoW6YYTJtE
</commit_message>
<xml_diff>
--- a/adpro/uber-presentation.pptx
+++ b/adpro/uber-presentation.pptx
@@ -2559,7 +2559,7 @@
         <p:spPr>
           <a:xfrm>
             <a:off x="566928" y="5010912"/>
-            <a:ext cx="3381146" cy="1234440"/>
+            <a:ext cx="3381146" cy="1097280"/>
           </a:xfrm>
           <a:prstGeom prst="rect">
             <a:avLst/>
@@ -2640,7 +2640,7 @@
         <p:spPr>
           <a:xfrm>
             <a:off x="4405274" y="5010912"/>
-            <a:ext cx="3381146" cy="1234440"/>
+            <a:ext cx="3381146" cy="1097280"/>
           </a:xfrm>
           <a:prstGeom prst="rect">
             <a:avLst/>
@@ -2721,7 +2721,7 @@
         <p:spPr>
           <a:xfrm>
             <a:off x="8243621" y="5010912"/>
-            <a:ext cx="3381146" cy="1234440"/>
+            <a:ext cx="3381146" cy="1097280"/>
           </a:xfrm>
           <a:prstGeom prst="rect">
             <a:avLst/>
@@ -2762,7 +2762,7 @@
         </p:nvSpPr>
         <p:spPr>
           <a:xfrm>
-            <a:off x="566928" y="6382512"/>
+            <a:off x="566928" y="6181344"/>
             <a:ext cx="4572000" cy="219456"/>
           </a:xfrm>
           <a:prstGeom prst="rect">
@@ -2801,7 +2801,7 @@
         </p:nvSpPr>
         <p:spPr>
           <a:xfrm>
-            <a:off x="10527487" y="6382512"/>
+            <a:off x="10527487" y="6181344"/>
             <a:ext cx="1097280" cy="219456"/>
           </a:xfrm>
           <a:prstGeom prst="rect">
@@ -3748,16 +3748,16 @@
         <p:spPr>
           <a:xfrm>
             <a:off x="5394960" y="5532120"/>
-            <a:ext cx="5760720" cy="777240"/>
-          </a:xfrm>
-          <a:prstGeom prst="rect">
-            <a:avLst/>
-          </a:prstGeom>
-          <a:noFill/>
-          <a:ln/>
-        </p:spPr>
-        <p:txBody>
-          <a:bodyPr wrap="square" lIns="0" tIns="0" rIns="0" bIns="0" rtlCol="0" anchor="ctr"/>
+            <a:ext cx="5760720" cy="566928"/>
+          </a:xfrm>
+          <a:prstGeom prst="rect">
+            <a:avLst/>
+          </a:prstGeom>
+          <a:noFill/>
+          <a:ln/>
+        </p:spPr>
+        <p:txBody>
+          <a:bodyPr wrap="square" lIns="0" tIns="0" rIns="0" bIns="0" rtlCol="0" anchor="t"/>
           <a:lstStyle/>
           <a:p>
             <a:pPr indent="0" marL="0">
@@ -3789,7 +3789,7 @@
         </p:nvSpPr>
         <p:spPr>
           <a:xfrm>
-            <a:off x="566928" y="6382512"/>
+            <a:off x="566928" y="6181344"/>
             <a:ext cx="4572000" cy="219456"/>
           </a:xfrm>
           <a:prstGeom prst="rect">
@@ -3828,7 +3828,7 @@
         </p:nvSpPr>
         <p:spPr>
           <a:xfrm>
-            <a:off x="10527487" y="6382512"/>
+            <a:off x="10527487" y="6181344"/>
             <a:ext cx="1097280" cy="219456"/>
           </a:xfrm>
           <a:prstGeom prst="rect">
@@ -5026,7 +5026,7 @@
         </p:nvSpPr>
         <p:spPr>
           <a:xfrm>
-            <a:off x="566928" y="6382512"/>
+            <a:off x="566928" y="6181344"/>
             <a:ext cx="4572000" cy="219456"/>
           </a:xfrm>
           <a:prstGeom prst="rect">
@@ -5065,7 +5065,7 @@
         </p:nvSpPr>
         <p:spPr>
           <a:xfrm>
-            <a:off x="10527487" y="6382512"/>
+            <a:off x="10527487" y="6181344"/>
             <a:ext cx="1097280" cy="219456"/>
           </a:xfrm>
           <a:prstGeom prst="rect">
@@ -5758,8 +5758,8 @@
         </p:nvSpPr>
         <p:spPr>
           <a:xfrm>
-            <a:off x="566928" y="5742432"/>
-            <a:ext cx="7955280" cy="566928"/>
+            <a:off x="566928" y="5577840"/>
+            <a:ext cx="7955280" cy="530352"/>
           </a:xfrm>
           <a:prstGeom prst="rect">
             <a:avLst/>
@@ -5800,7 +5800,7 @@
         </p:nvSpPr>
         <p:spPr>
           <a:xfrm>
-            <a:off x="566928" y="6382512"/>
+            <a:off x="566928" y="6181344"/>
             <a:ext cx="4572000" cy="219456"/>
           </a:xfrm>
           <a:prstGeom prst="rect">
@@ -5839,7 +5839,7 @@
         </p:nvSpPr>
         <p:spPr>
           <a:xfrm>
-            <a:off x="10527487" y="6382512"/>
+            <a:off x="10527487" y="6181344"/>
             <a:ext cx="1097280" cy="219456"/>
           </a:xfrm>
           <a:prstGeom prst="rect">
@@ -6541,8 +6541,8 @@
         </p:nvSpPr>
         <p:spPr>
           <a:xfrm>
-            <a:off x="566928" y="5989320"/>
-            <a:ext cx="11057839" cy="274320"/>
+            <a:off x="566928" y="5870448"/>
+            <a:ext cx="11057839" cy="310896"/>
           </a:xfrm>
           <a:prstGeom prst="rect">
             <a:avLst/>
@@ -6580,7 +6580,7 @@
         </p:nvSpPr>
         <p:spPr>
           <a:xfrm>
-            <a:off x="566928" y="6382512"/>
+            <a:off x="566928" y="6181344"/>
             <a:ext cx="4572000" cy="219456"/>
           </a:xfrm>
           <a:prstGeom prst="rect">
@@ -6619,7 +6619,7 @@
         </p:nvSpPr>
         <p:spPr>
           <a:xfrm>
-            <a:off x="10527487" y="6382512"/>
+            <a:off x="10527487" y="6181344"/>
             <a:ext cx="1097280" cy="219456"/>
           </a:xfrm>
           <a:prstGeom prst="rect">
@@ -6874,7 +6874,7 @@
             <a:r>
               <a:rPr lang="en-US" sz="1100" dirty="0">
                 <a:solidFill>
-                  <a:srgbClr val="6BA3E8"/>
+                  <a:srgbClr val="B9CCE4"/>
                 </a:solidFill>
                 <a:latin typeface="Arial" pitchFamily="34" charset="0"/>
                 <a:ea typeface="Arial" pitchFamily="34" charset="-122"/>
@@ -7463,7 +7463,7 @@
         </p:nvSpPr>
         <p:spPr>
           <a:xfrm>
-            <a:off x="566928" y="6382512"/>
+            <a:off x="566928" y="6181344"/>
             <a:ext cx="4572000" cy="219456"/>
           </a:xfrm>
           <a:prstGeom prst="rect">
@@ -7502,7 +7502,7 @@
         </p:nvSpPr>
         <p:spPr>
           <a:xfrm>
-            <a:off x="10527487" y="6382512"/>
+            <a:off x="10527487" y="6181344"/>
             <a:ext cx="1097280" cy="219456"/>
           </a:xfrm>
           <a:prstGeom prst="rect">
@@ -7687,7 +7687,7 @@
         </p:nvSpPr>
         <p:spPr>
           <a:xfrm>
-            <a:off x="566928" y="4617720"/>
+            <a:off x="566928" y="4480560"/>
             <a:ext cx="3381146" cy="256032"/>
           </a:xfrm>
           <a:prstGeom prst="rect">
@@ -7726,8 +7726,8 @@
         </p:nvSpPr>
         <p:spPr>
           <a:xfrm>
-            <a:off x="566928" y="4873752"/>
-            <a:ext cx="3381146" cy="512064"/>
+            <a:off x="566928" y="4736592"/>
+            <a:ext cx="3381146" cy="457200"/>
           </a:xfrm>
           <a:prstGeom prst="rect">
             <a:avLst/>
@@ -7768,7 +7768,7 @@
         </p:nvSpPr>
         <p:spPr>
           <a:xfrm>
-            <a:off x="4405274" y="4617720"/>
+            <a:off x="4405274" y="4480560"/>
             <a:ext cx="3381146" cy="256032"/>
           </a:xfrm>
           <a:prstGeom prst="rect">
@@ -7807,8 +7807,8 @@
         </p:nvSpPr>
         <p:spPr>
           <a:xfrm>
-            <a:off x="4405274" y="4873752"/>
-            <a:ext cx="3381146" cy="512064"/>
+            <a:off x="4405274" y="4736592"/>
+            <a:ext cx="3381146" cy="457200"/>
           </a:xfrm>
           <a:prstGeom prst="rect">
             <a:avLst/>
@@ -7849,7 +7849,7 @@
         </p:nvSpPr>
         <p:spPr>
           <a:xfrm>
-            <a:off x="8243621" y="4617720"/>
+            <a:off x="8243621" y="4480560"/>
             <a:ext cx="3381146" cy="256032"/>
           </a:xfrm>
           <a:prstGeom prst="rect">
@@ -7888,8 +7888,8 @@
         </p:nvSpPr>
         <p:spPr>
           <a:xfrm>
-            <a:off x="8243621" y="4873752"/>
-            <a:ext cx="3381146" cy="512064"/>
+            <a:off x="8243621" y="4736592"/>
+            <a:ext cx="3381146" cy="457200"/>
           </a:xfrm>
           <a:prstGeom prst="rect">
             <a:avLst/>
@@ -7930,7 +7930,7 @@
         </p:nvSpPr>
         <p:spPr>
           <a:xfrm>
-            <a:off x="566928" y="5486400"/>
+            <a:off x="566928" y="5349240"/>
             <a:ext cx="3381146" cy="256032"/>
           </a:xfrm>
           <a:prstGeom prst="rect">
@@ -7969,8 +7969,8 @@
         </p:nvSpPr>
         <p:spPr>
           <a:xfrm>
-            <a:off x="566928" y="5742432"/>
-            <a:ext cx="3381146" cy="512064"/>
+            <a:off x="566928" y="5605272"/>
+            <a:ext cx="3381146" cy="457200"/>
           </a:xfrm>
           <a:prstGeom prst="rect">
             <a:avLst/>
@@ -8011,7 +8011,7 @@
         </p:nvSpPr>
         <p:spPr>
           <a:xfrm>
-            <a:off x="4405274" y="5486400"/>
+            <a:off x="4405274" y="5349240"/>
             <a:ext cx="3381146" cy="256032"/>
           </a:xfrm>
           <a:prstGeom prst="rect">
@@ -8050,8 +8050,8 @@
         </p:nvSpPr>
         <p:spPr>
           <a:xfrm>
-            <a:off x="4405274" y="5742432"/>
-            <a:ext cx="3381146" cy="512064"/>
+            <a:off x="4405274" y="5605272"/>
+            <a:ext cx="3381146" cy="457200"/>
           </a:xfrm>
           <a:prstGeom prst="rect">
             <a:avLst/>
@@ -8092,7 +8092,7 @@
         </p:nvSpPr>
         <p:spPr>
           <a:xfrm>
-            <a:off x="8243621" y="5486400"/>
+            <a:off x="8243621" y="5349240"/>
             <a:ext cx="3381146" cy="256032"/>
           </a:xfrm>
           <a:prstGeom prst="rect">
@@ -8131,8 +8131,8 @@
         </p:nvSpPr>
         <p:spPr>
           <a:xfrm>
-            <a:off x="8243621" y="5742432"/>
-            <a:ext cx="3381146" cy="512064"/>
+            <a:off x="8243621" y="5605272"/>
+            <a:ext cx="3381146" cy="457200"/>
           </a:xfrm>
           <a:prstGeom prst="rect">
             <a:avLst/>
@@ -8173,7 +8173,7 @@
         </p:nvSpPr>
         <p:spPr>
           <a:xfrm>
-            <a:off x="566928" y="6327648"/>
+            <a:off x="566928" y="6126480"/>
             <a:ext cx="11057839" cy="274320"/>
           </a:xfrm>
           <a:prstGeom prst="rect">

</xml_diff>